<commit_message>
feat(templates): rebuild the interim report deck
Regenerated from the current template so the committed deck has the editor-safe shapes and explicit no-fill. It still carries placeholder presenter details only.

Co-Authored-By: Claude Opus 5.5 (1M context) <noreply@anthropic.com>
</commit_message>
<xml_diff>
--- a/templates/interim-report.pptx
+++ b/templates/interim-report.pptx
@@ -116,48 +116,48 @@
   <p:extLst>
     <p:ext uri="{521415D9-36F7-43E2-AB2F-B90AF26B5E84}">
       <p14:sectionLst xmlns:p14="http://schemas.microsoft.com/office/powerpoint/2010/main">
-        <p14:section name="표지" id="{01a5a09d-a1bf-2970-0c80-32d325aec017}">
+        <p14:section name="표지" id="{97a93edc-2103-845b-eab0-7a4f5019c405}">
           <p14:sldIdLst>
             <p14:sldId id="256"/>
           </p14:sldIdLst>
         </p14:section>
-        <p14:section name="Project Roadmap" id="{cd19174f-54ad-0a41-b733-13920cd68413}">
+        <p14:section name="Project Roadmap" id="{54be37ce-2fde-7576-addd-e91156c767df}">
           <p14:sldIdLst>
             <p14:sldId id="257"/>
           </p14:sldIdLst>
         </p14:section>
-        <p14:section name="Project FlowChart" id="{a3698d21-caad-31f3-12e8-8c58ae17b495}">
+        <p14:section name="Project FlowChart" id="{28afe0c5-27a1-e3cb-001b-99b4730a22bf}">
           <p14:sldIdLst>
             <p14:sldId id="258"/>
           </p14:sldIdLst>
         </p14:section>
-        <p14:section name="Phase 1 로봇 셋업" id="{4cbda0db-898e-ab93-167d-daf2704d67c3}">
+        <p14:section name="Phase 1 로봇 셋업" id="{80828e37-6117-f994-38ef-6c640b648334}">
           <p14:sldIdLst>
             <p14:sldId id="259"/>
           </p14:sldIdLst>
         </p14:section>
-        <p14:section name="Phase 2 카메라 셋업" id="{059935eb-b528-d678-8d00-63135fac78f9}">
+        <p14:section name="Phase 2 카메라 셋업" id="{26317e60-ac0e-9b2f-0004-02fca10ef020}">
           <p14:sldIdLst>
             <p14:sldId id="260"/>
           </p14:sldIdLst>
         </p14:section>
-        <p14:section name="Phase 3 대차 PLC 통합" id="{498f5066-bf17-6aad-924e-2ee3afec84aa}">
+        <p14:section name="Phase 3 대차 PLC 통합" id="{8aac5285-7c61-91bf-8e06-8b8c7d1e6d22}">
           <p14:sldIdLst>
             <p14:sldId id="261"/>
           </p14:sldIdLst>
         </p14:section>
-        <p14:section name="Phase 4 전체 시퀀스 테스트" id="{0a35a2f7-8a2f-d5a6-c8db-8f987c158033}">
+        <p14:section name="Phase 4 전체 시퀀스 테스트" id="{488e06e4-dd75-d7dc-bd7c-cee3694fb075}">
           <p14:sldIdLst>
             <p14:sldId id="262"/>
           </p14:sldIdLst>
         </p14:section>
-        <p14:section name="이슈 및 향후 계획" id="{006591c5-32b8-a308-d90b-2d47f0b72359}">
+        <p14:section name="이슈 및 향후 계획" id="{a05aae34-5b17-d99a-b6b8-6af65460b1c8}">
           <p14:sldIdLst>
             <p14:sldId id="263"/>
             <p14:sldId id="264"/>
           </p14:sldIdLst>
         </p14:section>
-        <p14:section name="마무리" id="{3087a175-8ec7-3149-45cd-2e5cf452aa09}">
+        <p14:section name="마무리" id="{661d7e39-5911-e05e-59a3-bbb3dfdde888}">
           <p14:sldIdLst>
             <p14:sldId id="265"/>
           </p14:sldIdLst>
@@ -1943,33 +1943,10 @@
       </p:sp>
       <p:sp>
         <p:nvSpPr>
-          <p:cNvPr id="4" name="Shape 2"/>
-          <p:cNvSpPr/>
-          <p:nvPr/>
-        </p:nvSpPr>
-        <p:spPr>
-          <a:xfrm>
-            <a:off x="11323015" y="6510528"/>
-            <a:ext cx="320040" cy="0"/>
-          </a:xfrm>
-          <a:prstGeom prst="line">
-            <a:avLst/>
-          </a:prstGeom>
-          <a:noFill/>
-          <a:ln w="6350">
-            <a:solidFill>
-              <a:schemeClr val="accent2"/>
-            </a:solidFill>
-            <a:prstDash val="solid"/>
-          </a:ln>
-        </p:spPr>
-      </p:sp>
-      <p:sp>
-        <p:nvSpPr>
-          <p:cNvPr id="5" name="Text 3"/>
+          <p:cNvPr id="4" name="Text 2"/>
           <p:cNvSpPr/>
           <p:nvPr>
-            <p:ph idx="103" type="title" hasCustomPrompt="1"/>
+            <p:ph idx="102" type="title" hasCustomPrompt="1"/>
           </p:nvPr>
         </p:nvSpPr>
         <p:spPr>
@@ -2024,6 +2001,7 @@
           <a:prstGeom prst="rect">
             <a:avLst/>
           </a:prstGeom>
+          <a:noFill/>
           <a:extLst>
             <a:ext uri="{C572A759-6A51-4108-AA02-DFA0A04FC94B}">
               <ma14:wrappingTextBoxFlag xmlns:ma14="http://schemas.microsoft.com/office/mac/drawingml/2011/main" val="0"/>
@@ -2105,29 +2083,6 @@
       </p:sp>
       <p:sp>
         <p:nvSpPr>
-          <p:cNvPr id="3" name="Shape 1"/>
-          <p:cNvSpPr/>
-          <p:nvPr/>
-        </p:nvSpPr>
-        <p:spPr>
-          <a:xfrm>
-            <a:off x="11323015" y="6510528"/>
-            <a:ext cx="320040" cy="0"/>
-          </a:xfrm>
-          <a:prstGeom prst="line">
-            <a:avLst/>
-          </a:prstGeom>
-          <a:noFill/>
-          <a:ln w="6350">
-            <a:solidFill>
-              <a:schemeClr val="accent2"/>
-            </a:solidFill>
-            <a:prstDash val="solid"/>
-          </a:ln>
-        </p:spPr>
-      </p:sp>
-      <p:sp>
-        <p:nvSpPr>
           <p:cNvPr id="25" name="Slide Number Placeholder 0"/>
           <p:cNvSpPr>
             <a:spLocks noGrp="1"/>
@@ -2144,6 +2099,7 @@
           <a:prstGeom prst="rect">
             <a:avLst/>
           </a:prstGeom>
+          <a:noFill/>
           <a:extLst>
             <a:ext uri="{C572A759-6A51-4108-AA02-DFA0A04FC94B}">
               <ma14:wrappingTextBoxFlag xmlns:ma14="http://schemas.microsoft.com/office/mac/drawingml/2011/main" val="0"/>
@@ -2211,19 +2167,16 @@
         </p:nvSpPr>
         <p:spPr>
           <a:xfrm>
-            <a:off x="822960" y="1463040"/>
-            <a:ext cx="0" cy="1371600"/>
-          </a:xfrm>
-          <a:prstGeom prst="line">
-            <a:avLst/>
-          </a:prstGeom>
-          <a:noFill/>
-          <a:ln w="12700">
-            <a:solidFill>
-              <a:schemeClr val="bg1"/>
-            </a:solidFill>
-            <a:prstDash val="solid"/>
-          </a:ln>
+            <a:off x="813816" y="1463040"/>
+            <a:ext cx="12802" cy="1371600"/>
+          </a:xfrm>
+          <a:prstGeom prst="rect">
+            <a:avLst/>
+          </a:prstGeom>
+          <a:solidFill>
+            <a:schemeClr val="bg1"/>
+          </a:solidFill>
+          <a:ln/>
         </p:spPr>
       </p:sp>
       <p:sp>
@@ -3979,6 +3932,7 @@
           <a:prstGeom prst="rect">
             <a:avLst/>
           </a:prstGeom>
+          <a:noFill/>
           <a:extLst>
             <a:ext uri="{C572A759-6A51-4108-AA02-DFA0A04FC94B}">
               <ma14:wrappingTextBoxFlag xmlns:ma14="http://schemas.microsoft.com/office/mac/drawingml/2011/main" val="0"/>
@@ -4812,6 +4766,7 @@
           <a:prstGeom prst="rect">
             <a:avLst/>
           </a:prstGeom>
+          <a:noFill/>
           <a:extLst>
             <a:ext uri="{C572A759-6A51-4108-AA02-DFA0A04FC94B}">
               <ma14:wrappingTextBoxFlag xmlns:ma14="http://schemas.microsoft.com/office/mac/drawingml/2011/main" val="0"/>
@@ -4866,10 +4821,10 @@
       </p:grpSpPr>
       <p:sp>
         <p:nvSpPr>
-          <p:cNvPr id="2" name="Text 3"/>
+          <p:cNvPr id="2" name="Text 2"/>
           <p:cNvSpPr/>
           <p:nvPr>
-            <p:ph idx="103" type="title" hasCustomPrompt="1"/>
+            <p:ph idx="102" type="title" hasCustomPrompt="1"/>
           </p:nvPr>
         </p:nvSpPr>
         <p:spPr>
@@ -5094,19 +5049,16 @@
         </p:nvSpPr>
         <p:spPr>
           <a:xfrm>
-            <a:off x="7452360" y="1865376"/>
-            <a:ext cx="0" cy="237744"/>
-          </a:xfrm>
-          <a:prstGeom prst="line">
-            <a:avLst/>
-          </a:prstGeom>
-          <a:noFill/>
-          <a:ln w="25400">
-            <a:solidFill>
-              <a:schemeClr val="tx2"/>
-            </a:solidFill>
-            <a:prstDash val="solid"/>
-          </a:ln>
+            <a:off x="7439558" y="1865376"/>
+            <a:ext cx="25603" cy="237744"/>
+          </a:xfrm>
+          <a:prstGeom prst="rect">
+            <a:avLst/>
+          </a:prstGeom>
+          <a:solidFill>
+            <a:schemeClr val="tx2"/>
+          </a:solidFill>
+          <a:ln/>
         </p:spPr>
       </p:sp>
       <p:sp>
@@ -5211,19 +5163,16 @@
         </p:nvSpPr>
         <p:spPr>
           <a:xfrm>
-            <a:off x="7452360" y="3202686"/>
-            <a:ext cx="0" cy="237744"/>
-          </a:xfrm>
-          <a:prstGeom prst="line">
-            <a:avLst/>
-          </a:prstGeom>
-          <a:noFill/>
-          <a:ln w="25400">
-            <a:solidFill>
-              <a:schemeClr val="tx2"/>
-            </a:solidFill>
-            <a:prstDash val="solid"/>
-          </a:ln>
+            <a:off x="7439558" y="3202686"/>
+            <a:ext cx="25603" cy="237744"/>
+          </a:xfrm>
+          <a:prstGeom prst="rect">
+            <a:avLst/>
+          </a:prstGeom>
+          <a:solidFill>
+            <a:schemeClr val="tx2"/>
+          </a:solidFill>
+          <a:ln/>
         </p:spPr>
       </p:sp>
       <p:sp>
@@ -5338,6 +5287,7 @@
           <a:prstGeom prst="rect">
             <a:avLst/>
           </a:prstGeom>
+          <a:noFill/>
           <a:extLst>
             <a:ext uri="{C572A759-6A51-4108-AA02-DFA0A04FC94B}">
               <ma14:wrappingTextBoxFlag xmlns:ma14="http://schemas.microsoft.com/office/mac/drawingml/2011/main" val="0"/>
@@ -5392,10 +5342,10 @@
       </p:grpSpPr>
       <p:sp>
         <p:nvSpPr>
-          <p:cNvPr id="2" name="Text 3"/>
+          <p:cNvPr id="2" name="Text 2"/>
           <p:cNvSpPr/>
           <p:nvPr>
-            <p:ph idx="103" type="title" hasCustomPrompt="1"/>
+            <p:ph idx="102" type="title" hasCustomPrompt="1"/>
           </p:nvPr>
         </p:nvSpPr>
         <p:spPr>
@@ -5765,19 +5715,16 @@
         </p:nvSpPr>
         <p:spPr>
           <a:xfrm>
-            <a:off x="7452360" y="1865376"/>
-            <a:ext cx="0" cy="237744"/>
-          </a:xfrm>
-          <a:prstGeom prst="line">
-            <a:avLst/>
-          </a:prstGeom>
-          <a:noFill/>
-          <a:ln w="25400">
-            <a:solidFill>
-              <a:schemeClr val="tx2"/>
-            </a:solidFill>
-            <a:prstDash val="solid"/>
-          </a:ln>
+            <a:off x="7439558" y="1865376"/>
+            <a:ext cx="25603" cy="237744"/>
+          </a:xfrm>
+          <a:prstGeom prst="rect">
+            <a:avLst/>
+          </a:prstGeom>
+          <a:solidFill>
+            <a:schemeClr val="tx2"/>
+          </a:solidFill>
+          <a:ln/>
         </p:spPr>
       </p:sp>
       <p:sp>
@@ -5882,19 +5829,16 @@
         </p:nvSpPr>
         <p:spPr>
           <a:xfrm>
-            <a:off x="7452360" y="3202686"/>
-            <a:ext cx="0" cy="237744"/>
-          </a:xfrm>
-          <a:prstGeom prst="line">
-            <a:avLst/>
-          </a:prstGeom>
-          <a:noFill/>
-          <a:ln w="25400">
-            <a:solidFill>
-              <a:schemeClr val="tx2"/>
-            </a:solidFill>
-            <a:prstDash val="solid"/>
-          </a:ln>
+            <a:off x="7439558" y="3202686"/>
+            <a:ext cx="25603" cy="237744"/>
+          </a:xfrm>
+          <a:prstGeom prst="rect">
+            <a:avLst/>
+          </a:prstGeom>
+          <a:solidFill>
+            <a:schemeClr val="tx2"/>
+          </a:solidFill>
+          <a:ln/>
         </p:spPr>
       </p:sp>
       <p:sp>
@@ -6009,6 +5953,7 @@
           <a:prstGeom prst="rect">
             <a:avLst/>
           </a:prstGeom>
+          <a:noFill/>
           <a:extLst>
             <a:ext uri="{C572A759-6A51-4108-AA02-DFA0A04FC94B}">
               <ma14:wrappingTextBoxFlag xmlns:ma14="http://schemas.microsoft.com/office/mac/drawingml/2011/main" val="0"/>
@@ -6063,10 +6008,10 @@
       </p:grpSpPr>
       <p:sp>
         <p:nvSpPr>
-          <p:cNvPr id="2" name="Text 3"/>
+          <p:cNvPr id="2" name="Text 2"/>
           <p:cNvSpPr/>
           <p:nvPr>
-            <p:ph idx="103" type="title" hasCustomPrompt="1"/>
+            <p:ph idx="102" type="title" hasCustomPrompt="1"/>
           </p:nvPr>
         </p:nvSpPr>
         <p:spPr>
@@ -6291,19 +6236,16 @@
         </p:nvSpPr>
         <p:spPr>
           <a:xfrm>
-            <a:off x="7452360" y="1865376"/>
-            <a:ext cx="0" cy="237744"/>
-          </a:xfrm>
-          <a:prstGeom prst="line">
-            <a:avLst/>
-          </a:prstGeom>
-          <a:noFill/>
-          <a:ln w="25400">
-            <a:solidFill>
-              <a:schemeClr val="tx2"/>
-            </a:solidFill>
-            <a:prstDash val="solid"/>
-          </a:ln>
+            <a:off x="7439558" y="1865376"/>
+            <a:ext cx="25603" cy="237744"/>
+          </a:xfrm>
+          <a:prstGeom prst="rect">
+            <a:avLst/>
+          </a:prstGeom>
+          <a:solidFill>
+            <a:schemeClr val="tx2"/>
+          </a:solidFill>
+          <a:ln/>
         </p:spPr>
       </p:sp>
       <p:sp>
@@ -6408,19 +6350,16 @@
         </p:nvSpPr>
         <p:spPr>
           <a:xfrm>
-            <a:off x="7452360" y="3202686"/>
-            <a:ext cx="0" cy="237744"/>
-          </a:xfrm>
-          <a:prstGeom prst="line">
-            <a:avLst/>
-          </a:prstGeom>
-          <a:noFill/>
-          <a:ln w="25400">
-            <a:solidFill>
-              <a:schemeClr val="tx2"/>
-            </a:solidFill>
-            <a:prstDash val="solid"/>
-          </a:ln>
+            <a:off x="7439558" y="3202686"/>
+            <a:ext cx="25603" cy="237744"/>
+          </a:xfrm>
+          <a:prstGeom prst="rect">
+            <a:avLst/>
+          </a:prstGeom>
+          <a:solidFill>
+            <a:schemeClr val="tx2"/>
+          </a:solidFill>
+          <a:ln/>
         </p:spPr>
       </p:sp>
       <p:sp>
@@ -6535,6 +6474,7 @@
           <a:prstGeom prst="rect">
             <a:avLst/>
           </a:prstGeom>
+          <a:noFill/>
           <a:extLst>
             <a:ext uri="{C572A759-6A51-4108-AA02-DFA0A04FC94B}">
               <ma14:wrappingTextBoxFlag xmlns:ma14="http://schemas.microsoft.com/office/mac/drawingml/2011/main" val="0"/>
@@ -6589,10 +6529,10 @@
       </p:grpSpPr>
       <p:sp>
         <p:nvSpPr>
-          <p:cNvPr id="2" name="Text 3"/>
+          <p:cNvPr id="2" name="Text 2"/>
           <p:cNvSpPr/>
           <p:nvPr>
-            <p:ph idx="103" type="title" hasCustomPrompt="1"/>
+            <p:ph idx="102" type="title" hasCustomPrompt="1"/>
           </p:nvPr>
         </p:nvSpPr>
         <p:spPr>
@@ -6817,19 +6757,16 @@
         </p:nvSpPr>
         <p:spPr>
           <a:xfrm>
-            <a:off x="7452360" y="1865376"/>
-            <a:ext cx="0" cy="237744"/>
-          </a:xfrm>
-          <a:prstGeom prst="line">
-            <a:avLst/>
-          </a:prstGeom>
-          <a:noFill/>
-          <a:ln w="25400">
-            <a:solidFill>
-              <a:schemeClr val="tx2"/>
-            </a:solidFill>
-            <a:prstDash val="solid"/>
-          </a:ln>
+            <a:off x="7439558" y="1865376"/>
+            <a:ext cx="25603" cy="237744"/>
+          </a:xfrm>
+          <a:prstGeom prst="rect">
+            <a:avLst/>
+          </a:prstGeom>
+          <a:solidFill>
+            <a:schemeClr val="tx2"/>
+          </a:solidFill>
+          <a:ln/>
         </p:spPr>
       </p:sp>
       <p:sp>
@@ -6916,19 +6853,16 @@
         </p:nvSpPr>
         <p:spPr>
           <a:xfrm>
-            <a:off x="7452360" y="2945511"/>
-            <a:ext cx="0" cy="237744"/>
-          </a:xfrm>
-          <a:prstGeom prst="line">
-            <a:avLst/>
-          </a:prstGeom>
-          <a:noFill/>
-          <a:ln w="25400">
-            <a:solidFill>
-              <a:schemeClr val="tx2"/>
-            </a:solidFill>
-            <a:prstDash val="solid"/>
-          </a:ln>
+            <a:off x="7439558" y="2945511"/>
+            <a:ext cx="25603" cy="237744"/>
+          </a:xfrm>
+          <a:prstGeom prst="rect">
+            <a:avLst/>
+          </a:prstGeom>
+          <a:solidFill>
+            <a:schemeClr val="tx2"/>
+          </a:solidFill>
+          <a:ln/>
         </p:spPr>
       </p:sp>
       <p:sp>
@@ -7025,6 +6959,7 @@
           <a:prstGeom prst="rect">
             <a:avLst/>
           </a:prstGeom>
+          <a:noFill/>
           <a:extLst>
             <a:ext uri="{C572A759-6A51-4108-AA02-DFA0A04FC94B}">
               <ma14:wrappingTextBoxFlag xmlns:ma14="http://schemas.microsoft.com/office/mac/drawingml/2011/main" val="0"/>
@@ -7079,10 +7014,10 @@
       </p:grpSpPr>
       <p:sp>
         <p:nvSpPr>
-          <p:cNvPr id="2" name="Text 3"/>
+          <p:cNvPr id="2" name="Text 2"/>
           <p:cNvSpPr/>
           <p:nvPr>
-            <p:ph idx="103" type="title" hasCustomPrompt="1"/>
+            <p:ph idx="102" type="title" hasCustomPrompt="1"/>
           </p:nvPr>
         </p:nvSpPr>
         <p:spPr>
@@ -7765,6 +7700,7 @@
           <a:prstGeom prst="rect">
             <a:avLst/>
           </a:prstGeom>
+          <a:noFill/>
           <a:extLst>
             <a:ext uri="{C572A759-6A51-4108-AA02-DFA0A04FC94B}">
               <ma14:wrappingTextBoxFlag xmlns:ma14="http://schemas.microsoft.com/office/mac/drawingml/2011/main" val="0"/>
@@ -7819,10 +7755,10 @@
       </p:grpSpPr>
       <p:sp>
         <p:nvSpPr>
-          <p:cNvPr id="2" name="Text 3"/>
+          <p:cNvPr id="2" name="Text 2"/>
           <p:cNvSpPr/>
           <p:nvPr>
-            <p:ph idx="103" type="title" hasCustomPrompt="1"/>
+            <p:ph idx="102" type="title" hasCustomPrompt="1"/>
           </p:nvPr>
         </p:nvSpPr>
         <p:spPr>
@@ -8531,6 +8467,7 @@
           <a:prstGeom prst="rect">
             <a:avLst/>
           </a:prstGeom>
+          <a:noFill/>
           <a:extLst>
             <a:ext uri="{C572A759-6A51-4108-AA02-DFA0A04FC94B}">
               <ma14:wrappingTextBoxFlag xmlns:ma14="http://schemas.microsoft.com/office/mac/drawingml/2011/main" val="0"/>

</xml_diff>